<commit_message>
refactor: humanizar identificadores a id_trabajador e id_cliente en PPT, Word, informe y scripts SQL
</commit_message>
<xml_diff>
--- a/PRESENTACION_EP2_ESTILO_URBANO.pptx
+++ b/PRESENTACION_EP2_ESTILO_URBANO.pptx
@@ -3189,7 +3189,7 @@
                 <a:ea typeface="Courier New" pitchFamily="34" charset="-122"/>
                 <a:cs typeface="Courier New" pitchFamily="34" charset="-120"/>
               </a:rPr>
-              <a:t>sp_actualizar_sueldo_empleado(p_id, p_sueldo)</a:t>
+              <a:t>sp_actualizar_sueldo_empleado(p_id_trabajador, p_sueldo)</a:t>
             </a:r>
             <a:endParaRPr lang="en-US" sz="1050" dirty="0"/>
           </a:p>
@@ -3228,7 +3228,7 @@
                 <a:ea typeface="Arial" pitchFamily="34" charset="-122"/>
                 <a:cs typeface="Arial" pitchFamily="34" charset="-120"/>
               </a:rPr>
-              <a:t>Actualiza el sueldo individual garantizando previamente que el usuario sea un trabajador activo mediante validación interna.</a:t>
+              <a:t>Actualiza el sueldo individual del trabajador garantizando previamente que sea un operador activo mediante validación interna.</a:t>
             </a:r>
             <a:endParaRPr lang="en-US" sz="950" dirty="0"/>
           </a:p>
@@ -4182,8 +4182,8 @@
                 <a:cs typeface="Courier New" pitchFamily="34" charset="-120"/>
               </a:rPr>
               <a:t>  PROCEDURE sp_actualizar_sueldo_empleado(
-    p_id_usuario   NUMBER,
-    p_nuevo_sueldo NUMBER
+    p_id_trabajador NUMBER,
+    p_nuevo_sueldo  NUMBER
   );
 </a:t>
             </a:r>
@@ -4412,12 +4412,12 @@
                 <a:cs typeface="Courier New" pitchFamily="34" charset="-120"/>
               </a:rPr>
               <a:t>  FUNCTION fn_es_trabajador_valido(
-    p_id_usuario NUMBER
+    p_id_trabajador NUMBER
   ) RETURN BOOLEAN IS
     v_count NUMBER;
   BEGIN
     SELECT COUNT(*) INTO v_count
-    FROM USUARIO WHERE id_usuario = p_id_usuario
+    FROM USUARIO WHERE id_usuario = p_id_trabajador
       AND id_rol = 2 AND estado = 'A';
     RETURN (v_count &gt; 0);
   END fn_es_trabajador_valido;
@@ -7772,7 +7772,7 @@
                 <a:ea typeface="Arial" pitchFamily="34" charset="-122"/>
                 <a:cs typeface="Arial" pitchFamily="34" charset="-120"/>
               </a:rPr>
-              <a:t>La lógica de negocio se ejecuta 100% en el motor Oracle Cloud ADB, garantizando integridad y eliminando vulnerabilidades en el cliente web.
+              <a:t>Lógica 100% en Oracle Cloud ADB, blindando el sistema contra modificaciones externas no autorizadas.
 </a:t>
             </a:r>
             <a:pPr indent="0" marL="0">
@@ -7801,7 +7801,7 @@
                 <a:ea typeface="Arial" pitchFamily="34" charset="-122"/>
                 <a:cs typeface="Arial" pitchFamily="34" charset="-120"/>
               </a:rPr>
-              <a:t>Ningún sueldo o pedido puede modificarse sin dejar registro histórico irreversible (:OLD y :NEW en auditoría, tracking de courier).
+              <a:t>Triggers con :OLD y :NEW registran cada alteración salarial y cambio de tracking en courier.
 </a:t>
             </a:r>
             <a:pPr indent="0" marL="0">
@@ -7830,7 +7830,36 @@
                 <a:ea typeface="Arial" pitchFamily="34" charset="-122"/>
                 <a:cs typeface="Arial" pitchFamily="34" charset="-120"/>
               </a:rPr>
-              <a:t>Los disparadores de sentencia previenen quiebras operacionales bloqueando de raíz nóminas superiores a las ventas del negocio.</a:t>
+              <a:t>Triggers de sentencia previenen quiebras bloqueando nóminas que superen las ventas del negocio.
+</a:t>
+            </a:r>
+            <a:pPr indent="0" marL="0">
+              <a:buNone/>
+            </a:pPr>
+            <a:r>
+              <a:rPr lang="en-US" sz="950" b="1" dirty="0">
+                <a:solidFill>
+                  <a:srgbClr val="F59E0B"/>
+                </a:solidFill>
+                <a:latin typeface="Arial" pitchFamily="34" charset="0"/>
+                <a:ea typeface="Arial" pitchFamily="34" charset="-122"/>
+                <a:cs typeface="Arial" pitchFamily="34" charset="-120"/>
+              </a:rPr>
+              <a:t>4. Vistas Semánticas (id_trabajador / id_cliente): </a:t>
+            </a:r>
+            <a:pPr indent="0" marL="0">
+              <a:buNone/>
+            </a:pPr>
+            <a:r>
+              <a:rPr lang="en-US" sz="950" dirty="0">
+                <a:solidFill>
+                  <a:srgbClr val="94A3B8"/>
+                </a:solidFill>
+                <a:latin typeface="Arial" pitchFamily="34" charset="0"/>
+                <a:ea typeface="Arial" pitchFamily="34" charset="-122"/>
+                <a:cs typeface="Arial" pitchFamily="34" charset="-120"/>
+              </a:rPr>
+              <a:t>V_TRABAJADORES y V_CLIENTES humanizan el modelo, eliminando identificadores robóticos.</a:t>
             </a:r>
             <a:endParaRPr lang="en-US" sz="950" dirty="0"/>
           </a:p>

</xml_diff>